<commit_message>
docs(submission): rename product IPOA to Stave in deck and script, frame IPOA as non-crypto data partner
</commit_message>
<xml_diff>
--- a/submission/Stave-pitch-deck.pptx
+++ b/submission/Stave-pitch-deck.pptx
@@ -1732,7 +1732,7 @@
                 <a:ea typeface="Georgia" pitchFamily="34" charset="-122"/>
                 <a:cs typeface="Georgia" pitchFamily="34" charset="-120"/>
               </a:rPr>
-              <a:t>IPOA</a:t>
+              <a:t>Stave</a:t>
             </a:r>
             <a:endParaRPr lang="en-US" sz="9600" dirty="0"/>
           </a:p>
@@ -3250,7 +3250,7 @@
                 <a:ea typeface="Georgia" pitchFamily="34" charset="-122"/>
                 <a:cs typeface="Georgia" pitchFamily="34" charset="-120"/>
               </a:rPr>
-              <a:t>IPOA — pricing infrastructure for music royalty finance.</a:t>
+              <a:t>Stave - pricing infrastructure for music royalty finance.</a:t>
             </a:r>
             <a:endParaRPr lang="en-US" sz="1200" dirty="0"/>
           </a:p>
@@ -4598,7 +4598,7 @@
                 <a:ea typeface="Calibri" pitchFamily="34" charset="-122"/>
                 <a:cs typeface="Calibri" pitchFamily="34" charset="-120"/>
               </a:rPr>
-              <a:t>WHAT IPOA IS</a:t>
+              <a:t>WHAT STAVE IS</a:t>
             </a:r>
             <a:endParaRPr lang="en-US" sz="1000" dirty="0"/>
           </a:p>
@@ -5009,7 +5009,7 @@
                 <a:ea typeface="Georgia" pitchFamily="34" charset="-122"/>
                 <a:cs typeface="Georgia" pitchFamily="34" charset="-120"/>
               </a:rPr>
-              <a:t>Royalty Risk Engine</a:t>
+              <a:t>Stave Risk Engine · IPOA data</a:t>
             </a:r>
             <a:endParaRPr lang="en-US" sz="1800" dirty="0"/>
           </a:p>
@@ -11784,7 +11784,7 @@
                 <a:ea typeface="Georgia" pitchFamily="34" charset="-122"/>
                 <a:cs typeface="Georgia" pitchFamily="34" charset="-120"/>
               </a:rPr>
-              <a:t>PRO ownership</a:t>
+              <a:t>IPOA partnership</a:t>
             </a:r>
             <a:endParaRPr lang="en-US" sz="1800" dirty="0"/>
           </a:p>
@@ -11823,7 +11823,7 @@
                 <a:ea typeface="Calibri" pitchFamily="34" charset="-122"/>
                 <a:cs typeface="Calibri" pitchFamily="34" charset="-120"/>
               </a:rPr>
-              <a:t>Ground-truth royalty data at the source — not scraped, not aggregated from DSP APIs.</a:t>
+              <a:t>IPOA, Georgia's traditional music rights organisation, gives Stave verified ownership and royalty data at the source. Not crypto, not scraped, not aggregated from DSP APIs.</a:t>
             </a:r>
             <a:endParaRPr lang="en-US" sz="1200" dirty="0"/>
           </a:p>

</xml_diff>